<commit_message>
Point the demo video link at the narrated version
</commit_message>
<xml_diff>
--- a/docs/Tripwire-Architecture.pptx
+++ b/docs/Tripwire-Architecture.pptx
@@ -119,39 +119,39 @@
   <p:extLst>
     <p:ext uri="{521415D9-36F7-43E2-AB2F-B90AF26B5E84}">
       <p14:sectionLst xmlns:p14="http://schemas.microsoft.com/office/powerpoint/2010/main">
-        <p14:section name="Overview" id="{259c92e8-c809-2917-ac92-0426a52c7806}">
+        <p14:section name="Overview" id="{14706304-534d-dc0c-1d18-61a00921c420}">
           <p14:sldIdLst>
             <p14:sldId id="256"/>
             <p14:sldId id="257"/>
             <p14:sldId id="258"/>
           </p14:sldIdLst>
         </p14:section>
-        <p14:section name="Process and decisions" id="{04eab6f2-8180-f755-81e8-2a69a80af463}">
+        <p14:section name="Process and decisions" id="{e56c8371-ddda-c565-1a37-3d3de5cdd138}">
           <p14:sldIdLst>
             <p14:sldId id="259"/>
             <p14:sldId id="260"/>
           </p14:sldIdLst>
         </p14:section>
-        <p14:section name="Inputs and models" id="{9375fd4c-1810-2aac-250f-29f0ede93cce}">
+        <p14:section name="Inputs and models" id="{e3b27193-da64-bc52-8b7b-374cdac0b5a1}">
           <p14:sldIdLst>
             <p14:sldId id="261"/>
             <p14:sldId id="262"/>
           </p14:sldIdLst>
         </p14:section>
-        <p14:section name="Control and safety" id="{29c65d70-1c20-33a7-a291-e497f14cd32a}">
+        <p14:section name="Control and safety" id="{eb7463de-d3f0-d93f-56cb-9e662d3f0e5a}">
           <p14:sldIdLst>
             <p14:sldId id="263"/>
             <p14:sldId id="264"/>
           </p14:sldIdLst>
         </p14:section>
-        <p14:section name="Evidence" id="{e6bd054a-24a2-cb58-e22c-2de96620ebae}">
+        <p14:section name="Evidence" id="{64eb7b37-0274-a1d1-9af2-87da1a49cc7e}">
           <p14:sldIdLst>
             <p14:sldId id="265"/>
             <p14:sldId id="266"/>
             <p14:sldId id="267"/>
           </p14:sldIdLst>
         </p14:section>
-        <p14:section name="Build" id="{cedaa729-d2b0-8e33-7f5e-90643c2e0fbf}">
+        <p14:section name="Build" id="{ee316516-7f71-52cb-ada9-82c257723f6e}">
           <p14:sldIdLst>
             <p14:sldId id="268"/>
           </p14:sldIdLst>

</xml_diff>